<commit_message>
docs: align submission scope and refresh presentation evidence
</commit_message>
<xml_diff>
--- a/docs/presentation/presentation.pptx
+++ b/docs/presentation/presentation.pptx
@@ -2,25 +2,25 @@
 <file path=ppt/presentation.xml><?xml version="1.0" encoding="utf-8"?>
 <p:presentation xmlns:p="http://schemas.openxmlformats.org/presentationml/2006/main">
   <p:sldMasterIdLst>
-    <p:sldMasterId xmlns:r="http://schemas.openxmlformats.org/officeDocument/2006/relationships" id="2147483648" r:id="R4da13af65beb4678"/>
+    <p:sldMasterId xmlns:r="http://schemas.openxmlformats.org/officeDocument/2006/relationships" id="2147483648" r:id="R71f53bac69b34993"/>
   </p:sldMasterIdLst>
   <p:notesMasterIdLst>
-    <p:notesMasterId xmlns:r="http://schemas.openxmlformats.org/officeDocument/2006/relationships" r:id="R4355ff762a1440ec"/>
+    <p:notesMasterId xmlns:r="http://schemas.openxmlformats.org/officeDocument/2006/relationships" r:id="R43033cfaa1554f52"/>
   </p:notesMasterIdLst>
   <p:sldIdLst>
-    <p:sldId xmlns:r="http://schemas.openxmlformats.org/officeDocument/2006/relationships" id="256" r:id="R106b14b5cccd4235"/>
-    <p:sldId xmlns:r="http://schemas.openxmlformats.org/officeDocument/2006/relationships" id="257" r:id="Re1643bbed6804875"/>
-    <p:sldId xmlns:r="http://schemas.openxmlformats.org/officeDocument/2006/relationships" id="258" r:id="R6b623cab93a942a0"/>
-    <p:sldId xmlns:r="http://schemas.openxmlformats.org/officeDocument/2006/relationships" id="259" r:id="R0d3d9d41c4c34566"/>
-    <p:sldId xmlns:r="http://schemas.openxmlformats.org/officeDocument/2006/relationships" id="260" r:id="Rfd1929290b0a440e"/>
-    <p:sldId xmlns:r="http://schemas.openxmlformats.org/officeDocument/2006/relationships" id="261" r:id="Rbfeb5b8aa25540a4"/>
-    <p:sldId xmlns:r="http://schemas.openxmlformats.org/officeDocument/2006/relationships" id="262" r:id="R6412bce29504498b"/>
-    <p:sldId xmlns:r="http://schemas.openxmlformats.org/officeDocument/2006/relationships" id="263" r:id="R71bb13d8a5dc409e"/>
-    <p:sldId xmlns:r="http://schemas.openxmlformats.org/officeDocument/2006/relationships" id="264" r:id="R3086453580354398"/>
-    <p:sldId xmlns:r="http://schemas.openxmlformats.org/officeDocument/2006/relationships" id="265" r:id="R352cd019573d449d"/>
-    <p:sldId xmlns:r="http://schemas.openxmlformats.org/officeDocument/2006/relationships" id="266" r:id="R6f29bfa3630d4487"/>
-    <p:sldId xmlns:r="http://schemas.openxmlformats.org/officeDocument/2006/relationships" id="267" r:id="Rc979b5b8602e49e4"/>
-    <p:sldId xmlns:r="http://schemas.openxmlformats.org/officeDocument/2006/relationships" id="268" r:id="R427906fdf21f42cf"/>
+    <p:sldId xmlns:r="http://schemas.openxmlformats.org/officeDocument/2006/relationships" id="256" r:id="R6411f445d9c4493c"/>
+    <p:sldId xmlns:r="http://schemas.openxmlformats.org/officeDocument/2006/relationships" id="257" r:id="Raff67e331a1e40c4"/>
+    <p:sldId xmlns:r="http://schemas.openxmlformats.org/officeDocument/2006/relationships" id="258" r:id="R6e317fbc5e8f4c23"/>
+    <p:sldId xmlns:r="http://schemas.openxmlformats.org/officeDocument/2006/relationships" id="259" r:id="Rfbab2f0678a64bae"/>
+    <p:sldId xmlns:r="http://schemas.openxmlformats.org/officeDocument/2006/relationships" id="260" r:id="R4137bc22fdf44d63"/>
+    <p:sldId xmlns:r="http://schemas.openxmlformats.org/officeDocument/2006/relationships" id="261" r:id="R31b3f980ac6b4ddb"/>
+    <p:sldId xmlns:r="http://schemas.openxmlformats.org/officeDocument/2006/relationships" id="262" r:id="R31a581d422054780"/>
+    <p:sldId xmlns:r="http://schemas.openxmlformats.org/officeDocument/2006/relationships" id="263" r:id="R970d163017374856"/>
+    <p:sldId xmlns:r="http://schemas.openxmlformats.org/officeDocument/2006/relationships" id="264" r:id="Rc09f88f4761942d7"/>
+    <p:sldId xmlns:r="http://schemas.openxmlformats.org/officeDocument/2006/relationships" id="265" r:id="Rf273c9cb4b154612"/>
+    <p:sldId xmlns:r="http://schemas.openxmlformats.org/officeDocument/2006/relationships" id="266" r:id="Raa64493e15774dfd"/>
+    <p:sldId xmlns:r="http://schemas.openxmlformats.org/officeDocument/2006/relationships" id="267" r:id="R820312024b2849e1"/>
+    <p:sldId xmlns:r="http://schemas.openxmlformats.org/officeDocument/2006/relationships" id="268" r:id="R953ec0c47d96474a"/>
   </p:sldIdLst>
   <p:sldSz cx="12192000" cy="6858000"/>
   <p:notesSz cx="6858000" cy="9144000"/>
@@ -3802,12 +3802,12 @@
   </p:cSld>
   <p:clrMap bg1="lt1" tx1="dk1" bg2="lt2" tx2="dk2" accent1="accent1" accent2="accent2" accent3="accent3" accent4="accent4" accent5="accent5" accent6="accent6" hlink="hlink" folHlink="folHlink"/>
   <p:sldLayoutIdLst>
-    <p:sldLayoutId xmlns:r="http://schemas.openxmlformats.org/officeDocument/2006/relationships" id="2147483649" r:id="R0d9003992f864c7f"/>
-    <p:sldLayoutId xmlns:r="http://schemas.openxmlformats.org/officeDocument/2006/relationships" id="2147483650" r:id="R3fcb98c018f5447a"/>
-    <p:sldLayoutId xmlns:r="http://schemas.openxmlformats.org/officeDocument/2006/relationships" id="2147483651" r:id="R27eaf4a6897d4ee9"/>
-    <p:sldLayoutId xmlns:r="http://schemas.openxmlformats.org/officeDocument/2006/relationships" id="2147483652" r:id="R7cdb0962858149f1"/>
-    <p:sldLayoutId xmlns:r="http://schemas.openxmlformats.org/officeDocument/2006/relationships" id="2147483653" r:id="R570fd0e274094010"/>
-    <p:sldLayoutId xmlns:r="http://schemas.openxmlformats.org/officeDocument/2006/relationships" id="2147483654" r:id="Rbbbca8813f604274"/>
+    <p:sldLayoutId xmlns:r="http://schemas.openxmlformats.org/officeDocument/2006/relationships" id="2147483649" r:id="R7fa4d22e98ae44e3"/>
+    <p:sldLayoutId xmlns:r="http://schemas.openxmlformats.org/officeDocument/2006/relationships" id="2147483650" r:id="R83583782afa1416c"/>
+    <p:sldLayoutId xmlns:r="http://schemas.openxmlformats.org/officeDocument/2006/relationships" id="2147483651" r:id="Rd4f827288f254ccc"/>
+    <p:sldLayoutId xmlns:r="http://schemas.openxmlformats.org/officeDocument/2006/relationships" id="2147483652" r:id="R67832741aa1f4601"/>
+    <p:sldLayoutId xmlns:r="http://schemas.openxmlformats.org/officeDocument/2006/relationships" id="2147483653" r:id="R13b01eac85244474"/>
+    <p:sldLayoutId xmlns:r="http://schemas.openxmlformats.org/officeDocument/2006/relationships" id="2147483654" r:id="R6ec6d2315f394bcd"/>
   </p:sldLayoutIdLst>
   <p:txStyles>
     <p:titleStyle>
@@ -6048,7 +6048,7 @@
                 <a:ea typeface="Noto Sans KR"/>
                 <a:cs typeface="Noto Sans KR"/>
               </a:rPr>
-              <a:t>2026.10.28 이용·응답. 전원 취업 준비생, 팀원 제외, 익명 평가 활용 동의.</a:t>
+              <a:t>2026.10.28 이용·응답. 개발 직무 준비생 5명, 팀원 제외·익명 활용 동의.</a:t>
             </a:r>
           </a:p>
         </p:txBody>
@@ -6396,7 +6396,7 @@
           <p:cNvPr id="5" name="">
             <a:extLst xmlns:a="http://schemas.openxmlformats.org/drawingml/2006/main">
               <a:ext uri="{FF2B5EF4-FFF2-40B4-BE49-F238E27FC236}">
-                <a16:creationId xmlns:a16="http://schemas.microsoft.com/office/drawing/2014/main" id="{141E1353-F46E-4BF0-B456-6234E181A05B}"/>
+                <a16:creationId xmlns:a16="http://schemas.microsoft.com/office/drawing/2014/main" id="{186FF293-605B-403C-B109-04E7EE3EB342}"/>
               </a:ext>
             </a:extLst>
           </p:cNvPr>
@@ -8262,7 +8262,7 @@
                 <a:ea typeface="Noto Sans KR"/>
                 <a:cs typeface="Noto Sans KR"/>
               </a:rPr>
-              <a:t>피드백 이후 서비스 기능 수정 없음</a:t>
+              <a:t>피드백에 따른 기능 수정 없음</a:t>
             </a:r>
           </a:p>
         </p:txBody>
@@ -8624,7 +8624,7 @@
                 <a:ea typeface="Noto Sans KR"/>
                 <a:cs typeface="Noto Sans KR"/>
               </a:rPr>
-              <a:t>의견 원문과 유지 판단을 문서에 남겼습니다.</a:t>
+              <a:t>긍정적 의견은 기능 유지로 반영했습니다.</a:t>
             </a:r>
           </a:p>
           <a:p xmlns:a="http://schemas.openxmlformats.org/drawingml/2006/main">
@@ -8648,7 +8648,7 @@
                 <a:ea typeface="Noto Sans KR"/>
                 <a:cs typeface="Noto Sans KR"/>
               </a:rPr>
-              <a:t>기존 공고 필터 수정을 이번 사용자 피드백의 성과로 소급하지 않았습니다.</a:t>
+              <a:t>후속 bb1885e 수정은 별도 기술 시험에서 발견한 상담·검색 오류에 따른 작업입니다.</a:t>
             </a:r>
           </a:p>
         </p:txBody>
@@ -9363,7 +9363,7 @@
           <p:cNvPr id="5" name="">
             <a:extLst xmlns:a="http://schemas.openxmlformats.org/drawingml/2006/main">
               <a:ext uri="{FF2B5EF4-FFF2-40B4-BE49-F238E27FC236}">
-                <a16:creationId xmlns:a16="http://schemas.microsoft.com/office/drawing/2014/main" id="{9DBD9C71-7727-4CD1-A710-02DF34519C30}"/>
+                <a16:creationId xmlns:a16="http://schemas.microsoft.com/office/drawing/2014/main" id="{DFD45A0A-671D-443F-AA33-9A0C464D1BE8}"/>
               </a:ext>
             </a:extLst>
           </p:cNvPr>
@@ -10093,7 +10093,7 @@
                 <a:ea typeface="Noto Sans KR"/>
                 <a:cs typeface="Noto Sans KR"/>
               </a:rPr>
-              <a:t>AI 생성 정보 고지와 외부 전송 동의, 서버의 미동의 차단을 적용했습니다.</a:t>
+              <a:t>AI 고지·화면 동의 차단·서버 미동의 403 응답 3회를 확인했습니다.</a:t>
             </a:r>
           </a:p>
           <a:p xmlns:a="http://schemas.openxmlformats.org/drawingml/2006/main">
@@ -10117,18 +10117,7 @@
                 <a:ea typeface="Noto Sans KR"/>
                 <a:cs typeface="Noto Sans KR"/>
               </a:rPr>
-              <a:t>피드백은 T1~T5로 기록합니다. </a:t>
-            </a:r>
-            <a:r>
-              <a:rPr sz="1875" b="0">
-                <a:solidFill>
-                  <a:srgbClr val="152B4B"/>
-                </a:solidFill>
-                <a:latin typeface="Noto Sans KR"/>
-                <a:ea typeface="Noto Sans KR"/>
-                <a:cs typeface="Noto Sans KR"/>
-              </a:rPr>
-              <a:t>세 명의 본인 기여 요약과 대표 커밋을 문서로 남겼습니다.</a:t>
+              <a:t>세 명의 기여 요약을 작성했고, 키 폐기·피드백 익명 처리는 담당자가 확인했습니다.</a:t>
             </a:r>
           </a:p>
         </p:txBody>
@@ -11195,7 +11184,7 @@
                 <a:ea typeface="Noto Sans KR"/>
                 <a:cs typeface="Noto Sans KR"/>
               </a:rPr>
-              <a:t>이미지 답변의 무관한 출처와 Markdown 원문 표시가 남아 있습니다.</a:t>
+              <a:t>무관한 출처·Markdown 원문·내부 처리 표시·민감 정보 질문은 개선점입니다.</a:t>
             </a:r>
           </a:p>
           <a:p xmlns:a="http://schemas.openxmlformats.org/drawingml/2006/main">
@@ -11219,7 +11208,7 @@
                 <a:ea typeface="Noto Sans KR"/>
                 <a:cs typeface="Noto Sans KR"/>
               </a:rPr>
-              <a:t>원래 직무 추천 요구와 현재 공고 후보 검색의 범위를 최종 대조해야 합니다.</a:t>
+              <a:t>초기 명세의 공고 추천 범위를 기준으로 구현·검증 결과를 정리했습니다.</a:t>
             </a:r>
           </a:p>
           <a:p xmlns:a="http://schemas.openxmlformats.org/drawingml/2006/main">
@@ -11243,7 +11232,7 @@
                 <a:ea typeface="Noto Sans KR"/>
                 <a:cs typeface="Noto Sans KR"/>
               </a:rPr>
-              <a:t>Must 최종 검증·타깃 근거·수집 질문·익명 처리·키 폐기를 확인합니다.</a:t>
+              <a:t>남은 텍스트 회귀 확인과 제출 링크·서비스 유지 상태를 최종 점검합니다.</a:t>
             </a:r>
           </a:p>
         </p:txBody>
@@ -13773,7 +13762,7 @@
           <p:cNvPr id="5" name="">
             <a:extLst xmlns:a="http://schemas.openxmlformats.org/drawingml/2006/main">
               <a:ext uri="{FF2B5EF4-FFF2-40B4-BE49-F238E27FC236}">
-                <a16:creationId xmlns:a16="http://schemas.microsoft.com/office/drawing/2014/main" id="{DE92A8EE-C8DE-4964-8B8A-88999589BB40}"/>
+                <a16:creationId xmlns:a16="http://schemas.microsoft.com/office/drawing/2014/main" id="{24B1DC82-5330-4CD7-BAE5-DFC79BFE7303}"/>
               </a:ext>
             </a:extLst>
           </p:cNvPr>
@@ -15349,7 +15338,7 @@
           <p:cNvPr id="5" name="">
             <a:extLst xmlns:a="http://schemas.openxmlformats.org/drawingml/2006/main">
               <a:ext uri="{FF2B5EF4-FFF2-40B4-BE49-F238E27FC236}">
-                <a16:creationId xmlns:a16="http://schemas.microsoft.com/office/drawing/2014/main" id="{EF78BEE1-2146-4708-9A65-ABDFE1829CBD}"/>
+                <a16:creationId xmlns:a16="http://schemas.microsoft.com/office/drawing/2014/main" id="{8228A59C-DBB8-4D60-81E8-C218C1408190}"/>
               </a:ext>
             </a:extLst>
           </p:cNvPr>
@@ -16925,7 +16914,7 @@
           <p:cNvPr id="5" name="">
             <a:extLst xmlns:a="http://schemas.openxmlformats.org/drawingml/2006/main">
               <a:ext uri="{FF2B5EF4-FFF2-40B4-BE49-F238E27FC236}">
-                <a16:creationId xmlns:a16="http://schemas.microsoft.com/office/drawing/2014/main" id="{D22DBA72-DB66-4A45-B220-D87E51694A43}"/>
+                <a16:creationId xmlns:a16="http://schemas.microsoft.com/office/drawing/2014/main" id="{0340CA27-F10B-4990-BB98-F9B28967A427}"/>
               </a:ext>
             </a:extLst>
           </p:cNvPr>
@@ -18723,7 +18712,7 @@
           <p:cNvPr id="7" name="">
             <a:extLst xmlns:a="http://schemas.openxmlformats.org/drawingml/2006/main">
               <a:ext uri="{FF2B5EF4-FFF2-40B4-BE49-F238E27FC236}">
-                <a16:creationId xmlns:a16="http://schemas.microsoft.com/office/drawing/2014/main" id="{545F0997-F45D-4D68-865A-8703C5CA386E}"/>
+                <a16:creationId xmlns:a16="http://schemas.microsoft.com/office/drawing/2014/main" id="{4272FD53-C9E3-4825-A8A0-16E6C825C3A9}"/>
               </a:ext>
             </a:extLst>
           </p:cNvPr>
@@ -19649,7 +19638,7 @@
                 <a:ea typeface="Noto Sans KR"/>
                 <a:cs typeface="Noto Sans KR"/>
               </a:rPr>
-              <a:t>아래 수정은 사용자 피드백 수집 이전의 기술 검증에 따른 작업입니다.</a:t>
+              <a:t>초기 검색 필터와 후속 상담 오류를 기술 검증으로 보완했습니다.</a:t>
             </a:r>
           </a:p>
         </p:txBody>
@@ -19997,7 +19986,7 @@
           <p:cNvPr id="5" name="">
             <a:extLst xmlns:a="http://schemas.openxmlformats.org/drawingml/2006/main">
               <a:ext uri="{FF2B5EF4-FFF2-40B4-BE49-F238E27FC236}">
-                <a16:creationId xmlns:a16="http://schemas.microsoft.com/office/drawing/2014/main" id="{49F9D535-1DE6-4F22-803C-8498E07972B9}"/>
+                <a16:creationId xmlns:a16="http://schemas.microsoft.com/office/drawing/2014/main" id="{B0198857-54CE-4107-8787-125690D35F45}"/>
               </a:ext>
             </a:extLst>
           </p:cNvPr>
@@ -20408,7 +20397,7 @@
                           <a:ea typeface="Noto Sans KR"/>
                           <a:cs typeface="Noto Sans KR"/>
                         </a:rPr>
-                        <a:t>인크루트 ASP 검색 목록 누락</a:t>
+                        <a:t>목록 누락·일반 상담 계획 오류</a:t>
                       </a:r>
                     </a:p>
                   </a:txBody>
@@ -20455,7 +20444,7 @@
                           <a:ea typeface="Noto Sans KR"/>
                           <a:cs typeface="Noto Sans KR"/>
                         </a:rPr>
-                        <a:t>jobdb_list 경로 제외와 재현 검사 추가</a:t>
+                        <a:t>목록 필터·도구 없는 상담·검색 거부 처리</a:t>
                       </a:r>
                     </a:p>
                   </a:txBody>
@@ -20646,7 +20635,7 @@
                 <a:ea typeface="Noto Sans KR"/>
                 <a:cs typeface="Noto Sans KR"/>
               </a:rPr>
-              <a:t>인크루트 보완 후 배포 재검증에서 해당 목록의 미노출을 확인했습니다. 모든 사이트를 보장하지는 않습니다.</a:t>
+              <a:t>초기 필터 보완 후 bb1885e에서 상담·검색 의도 처리를 보완했습니다. 모든 사이트를 보장하지는 않습니다.</a:t>
             </a:r>
           </a:p>
         </p:txBody>
@@ -21013,7 +21002,7 @@
                 <a:ea typeface="Noto Sans KR"/>
                 <a:cs typeface="Noto Sans KR"/>
               </a:rPr>
-              <a:t>자동 검사와 실제 서비스 시험을 구분해 기록했습니다.</a:t>
+              <a:t>수정 전 시험과 bb1885e의 선택 회귀 시험을 구분했습니다.</a:t>
             </a:r>
           </a:p>
         </p:txBody>
@@ -21361,7 +21350,7 @@
           <p:cNvPr id="5" name="">
             <a:extLst xmlns:a="http://schemas.openxmlformats.org/drawingml/2006/main">
               <a:ext uri="{FF2B5EF4-FFF2-40B4-BE49-F238E27FC236}">
-                <a16:creationId xmlns:a16="http://schemas.microsoft.com/office/drawing/2014/main" id="{73F3B3CE-FF95-4125-8A56-E87D478AF6D8}"/>
+                <a16:creationId xmlns:a16="http://schemas.microsoft.com/office/drawing/2014/main" id="{F8F87CDB-BFA0-4631-AA14-D5CDD3D98D50}"/>
               </a:ext>
             </a:extLst>
           </p:cNvPr>
@@ -21597,7 +21586,7 @@
                           <a:ea typeface="Noto Sans KR"/>
                           <a:cs typeface="Noto Sans KR"/>
                         </a:rPr>
-                        <a:t>백엔드·프론트엔드·pandas 질문</a:t>
+                        <a:t>수정 전 백엔드·프론트·pandas 3회</a:t>
                       </a:r>
                     </a:p>
                   </a:txBody>
@@ -21638,7 +21627,7 @@
                           <a:ea typeface="Noto Sans KR"/>
                           <a:cs typeface="Noto Sans KR"/>
                         </a:rPr>
-                        <a:t>관련 문단·출처 확인</a:t>
+                        <a:t>3/3 문단·출처·조언 확인</a:t>
                       </a:r>
                     </a:p>
                   </a:txBody>
@@ -21728,7 +21717,7 @@
                           <a:ea typeface="Noto Sans KR"/>
                           <a:cs typeface="Noto Sans KR"/>
                         </a:rPr>
-                        <a:t>3종 검색과 목록 누락 재검증</a:t>
+                        <a:t>수정 전 3종 / 수정 후 Python 1회</a:t>
                       </a:r>
                     </a:p>
                   </a:txBody>
@@ -21769,7 +21758,7 @@
                           <a:ea typeface="Noto Sans KR"/>
                           <a:cs typeface="Noto Sans KR"/>
                         </a:rPr>
-                        <a:t>필터 동작 확인 / 모집 상태는 미확인</a:t>
+                        <a:t>후보·링크 확인 / 모집 상태 미확인</a:t>
                       </a:r>
                     </a:p>
                   </a:txBody>
@@ -21859,7 +21848,7 @@
                           <a:ea typeface="Noto Sans KR"/>
                           <a:cs typeface="Noto Sans KR"/>
                         </a:rPr>
-                        <a:t>3개 입력 사례</a:t>
+                        <a:t>수정 전 3개 입력 사례</a:t>
                       </a:r>
                     </a:p>
                   </a:txBody>
@@ -21900,7 +21889,7 @@
                           <a:ea typeface="Noto Sans KR"/>
                           <a:cs typeface="Noto Sans KR"/>
                         </a:rPr>
-                        <a:t>일치·차이·정보 부족 분류 확인</a:t>
+                        <a:t>2/3 충족·1회 부분 충족</a:t>
                       </a:r>
                     </a:p>
                   </a:txBody>
@@ -22222,7 +22211,7 @@
                 <a:ea typeface="Noto Sans KR"/>
                 <a:cs typeface="Noto Sans KR"/>
               </a:rPr>
-              <a:t>자동 검사 74개 통과 기록이 있습니다. 버전별 실패·부분 성공은 보존하며, 실사용자 피드백과 합산하지 않습니다.</a:t>
+              <a:t>기존 74개·보완 97개 자동 검사 기록. 수정 전 시험과 최신 회귀 결과는 합산하지 않습니다.</a:t>
             </a:r>
           </a:p>
         </p:txBody>
@@ -22937,7 +22926,7 @@
           <p:cNvPr id="5" name="">
             <a:extLst xmlns:a="http://schemas.openxmlformats.org/drawingml/2006/main">
               <a:ext uri="{FF2B5EF4-FFF2-40B4-BE49-F238E27FC236}">
-                <a16:creationId xmlns:a16="http://schemas.microsoft.com/office/drawing/2014/main" id="{53387AC6-6733-4870-9BD5-75212AD377CB}"/>
+                <a16:creationId xmlns:a16="http://schemas.microsoft.com/office/drawing/2014/main" id="{B81951E7-1FB8-4E64-8E57-1ACDDFED0514}"/>
               </a:ext>
             </a:extLst>
           </p:cNvPr>
@@ -22947,7 +22936,7 @@
           <p:nvPr/>
         </p:nvPicPr>
         <p:blipFill>
-          <a:blip xmlns:r="http://schemas.openxmlformats.org/officeDocument/2006/relationships" xmlns:a="http://schemas.openxmlformats.org/drawingml/2006/main" r:embed="R6db55ef0c8254eb5"/>
+          <a:blip xmlns:r="http://schemas.openxmlformats.org/officeDocument/2006/relationships" xmlns:a="http://schemas.openxmlformats.org/drawingml/2006/main" r:embed="R6056c86905764d42"/>
           <a:stretch xmlns:a="http://schemas.openxmlformats.org/drawingml/2006/main"/>
         </p:blipFill>
         <p:spPr>

</xml_diff>

<commit_message>
docs: record latest API verification and refresh presentation
</commit_message>
<xml_diff>
--- a/docs/presentation/presentation.pptx
+++ b/docs/presentation/presentation.pptx
@@ -2,25 +2,25 @@
 <file path=ppt/presentation.xml><?xml version="1.0" encoding="utf-8"?>
 <p:presentation xmlns:p="http://schemas.openxmlformats.org/presentationml/2006/main">
   <p:sldMasterIdLst>
-    <p:sldMasterId xmlns:r="http://schemas.openxmlformats.org/officeDocument/2006/relationships" id="2147483648" r:id="R71f53bac69b34993"/>
+    <p:sldMasterId xmlns:r="http://schemas.openxmlformats.org/officeDocument/2006/relationships" id="2147483648" r:id="R9045f5373f184d15"/>
   </p:sldMasterIdLst>
   <p:notesMasterIdLst>
-    <p:notesMasterId xmlns:r="http://schemas.openxmlformats.org/officeDocument/2006/relationships" r:id="R43033cfaa1554f52"/>
+    <p:notesMasterId xmlns:r="http://schemas.openxmlformats.org/officeDocument/2006/relationships" r:id="Ra58a87526853478a"/>
   </p:notesMasterIdLst>
   <p:sldIdLst>
-    <p:sldId xmlns:r="http://schemas.openxmlformats.org/officeDocument/2006/relationships" id="256" r:id="R6411f445d9c4493c"/>
-    <p:sldId xmlns:r="http://schemas.openxmlformats.org/officeDocument/2006/relationships" id="257" r:id="Raff67e331a1e40c4"/>
-    <p:sldId xmlns:r="http://schemas.openxmlformats.org/officeDocument/2006/relationships" id="258" r:id="R6e317fbc5e8f4c23"/>
-    <p:sldId xmlns:r="http://schemas.openxmlformats.org/officeDocument/2006/relationships" id="259" r:id="Rfbab2f0678a64bae"/>
-    <p:sldId xmlns:r="http://schemas.openxmlformats.org/officeDocument/2006/relationships" id="260" r:id="R4137bc22fdf44d63"/>
-    <p:sldId xmlns:r="http://schemas.openxmlformats.org/officeDocument/2006/relationships" id="261" r:id="R31b3f980ac6b4ddb"/>
-    <p:sldId xmlns:r="http://schemas.openxmlformats.org/officeDocument/2006/relationships" id="262" r:id="R31a581d422054780"/>
-    <p:sldId xmlns:r="http://schemas.openxmlformats.org/officeDocument/2006/relationships" id="263" r:id="R970d163017374856"/>
-    <p:sldId xmlns:r="http://schemas.openxmlformats.org/officeDocument/2006/relationships" id="264" r:id="Rc09f88f4761942d7"/>
-    <p:sldId xmlns:r="http://schemas.openxmlformats.org/officeDocument/2006/relationships" id="265" r:id="Rf273c9cb4b154612"/>
-    <p:sldId xmlns:r="http://schemas.openxmlformats.org/officeDocument/2006/relationships" id="266" r:id="Raa64493e15774dfd"/>
-    <p:sldId xmlns:r="http://schemas.openxmlformats.org/officeDocument/2006/relationships" id="267" r:id="R820312024b2849e1"/>
-    <p:sldId xmlns:r="http://schemas.openxmlformats.org/officeDocument/2006/relationships" id="268" r:id="R953ec0c47d96474a"/>
+    <p:sldId xmlns:r="http://schemas.openxmlformats.org/officeDocument/2006/relationships" id="256" r:id="Re89b53c03b664748"/>
+    <p:sldId xmlns:r="http://schemas.openxmlformats.org/officeDocument/2006/relationships" id="257" r:id="Re2136ef7367b47ad"/>
+    <p:sldId xmlns:r="http://schemas.openxmlformats.org/officeDocument/2006/relationships" id="258" r:id="Rad409e6d288443e3"/>
+    <p:sldId xmlns:r="http://schemas.openxmlformats.org/officeDocument/2006/relationships" id="259" r:id="R9e21099f526d4c2e"/>
+    <p:sldId xmlns:r="http://schemas.openxmlformats.org/officeDocument/2006/relationships" id="260" r:id="R4101a32b0c28406d"/>
+    <p:sldId xmlns:r="http://schemas.openxmlformats.org/officeDocument/2006/relationships" id="261" r:id="Rb5a8b14635484f61"/>
+    <p:sldId xmlns:r="http://schemas.openxmlformats.org/officeDocument/2006/relationships" id="262" r:id="Rff0daa595e9145b7"/>
+    <p:sldId xmlns:r="http://schemas.openxmlformats.org/officeDocument/2006/relationships" id="263" r:id="R543570dc08074003"/>
+    <p:sldId xmlns:r="http://schemas.openxmlformats.org/officeDocument/2006/relationships" id="264" r:id="Reae3fd6ee0f74285"/>
+    <p:sldId xmlns:r="http://schemas.openxmlformats.org/officeDocument/2006/relationships" id="265" r:id="Rdb61409a960545b6"/>
+    <p:sldId xmlns:r="http://schemas.openxmlformats.org/officeDocument/2006/relationships" id="266" r:id="R1a70af13fae3484b"/>
+    <p:sldId xmlns:r="http://schemas.openxmlformats.org/officeDocument/2006/relationships" id="267" r:id="Rc1fe51597feb4584"/>
+    <p:sldId xmlns:r="http://schemas.openxmlformats.org/officeDocument/2006/relationships" id="268" r:id="R0fe67e8af96c481a"/>
   </p:sldIdLst>
   <p:sldSz cx="12192000" cy="6858000"/>
   <p:notesSz cx="6858000" cy="9144000"/>
@@ -607,6 +607,16 @@
               <a:t>출처: https://github.com/SonJH0/aisupport/blob/main/docs/사용자-피드백-기록.md</a:t>
             </a:r>
           </a:p>
+          <a:p xmlns:a="http://schemas.openxmlformats.org/drawingml/2006/main">
+            <a:r>
+              <a:t>최신 원문·판정: https://github.com/SonJH0/aisupport/blob/main/docs/verification/latest-text-revalidation.md</a:t>
+            </a:r>
+          </a:p>
+          <a:p xmlns:a="http://schemas.openxmlformats.org/drawingml/2006/main">
+            <a:r>
+              <a:t>수집 스크립트는 실행 중 배포 SHA를 독립 관찰하지 않았다. 최신 비교 3/3, 상담 1건·검색 2건의 선택 시험. 전체 기능 새 3회 시험으로 합산하지 않는다.</a:t>
+            </a:r>
+          </a:p>
         </p:txBody>
       </p:sp>
       <p:sp>
@@ -760,6 +770,16 @@
           <a:p xmlns:a="http://schemas.openxmlformats.org/drawingml/2006/main">
             <a:r>
               <a:t>출처: https://github.com/SonJH0/aisupport/blob/main/docs/요구사항-정의서.md</a:t>
+            </a:r>
+          </a:p>
+          <a:p xmlns:a="http://schemas.openxmlformats.org/drawingml/2006/main">
+            <a:r>
+              <a:t>최신 원문·판정: https://github.com/SonJH0/aisupport/blob/main/docs/verification/latest-text-revalidation.md</a:t>
+            </a:r>
+          </a:p>
+          <a:p xmlns:a="http://schemas.openxmlformats.org/drawingml/2006/main">
+            <a:r>
+              <a:t>수집 스크립트는 실행 중 배포 SHA를 독립 관찰하지 않았다. 최신 비교 3/3, 상담 1건·검색 2건의 선택 시험. 전체 기능 새 3회 시험으로 합산하지 않는다.</a:t>
             </a:r>
           </a:p>
         </p:txBody>
@@ -1207,6 +1227,16 @@
               <a:t>출처: https://github.com/SonJH0/aisupport/commit/e101485</a:t>
             </a:r>
           </a:p>
+          <a:p xmlns:a="http://schemas.openxmlformats.org/drawingml/2006/main">
+            <a:r>
+              <a:t>최신 원문·판정: https://github.com/SonJH0/aisupport/blob/main/docs/verification/latest-text-revalidation.md</a:t>
+            </a:r>
+          </a:p>
+          <a:p xmlns:a="http://schemas.openxmlformats.org/drawingml/2006/main">
+            <a:r>
+              <a:t>수집 스크립트는 실행 중 배포 SHA를 독립 관찰하지 않았다. 최신 비교 3/3, 상담 1건·검색 2건의 선택 시험. 전체 기능 새 3회 시험으로 합산하지 않는다.</a:t>
+            </a:r>
+          </a:p>
         </p:txBody>
       </p:sp>
       <p:sp>
@@ -1285,6 +1315,16 @@
           <a:p xmlns:a="http://schemas.openxmlformats.org/drawingml/2006/main">
             <a:r>
               <a:t>출처: https://github.com/SonJH0/aisupport/blob/main/docs/image-validation/image-validation.md</a:t>
+            </a:r>
+          </a:p>
+          <a:p xmlns:a="http://schemas.openxmlformats.org/drawingml/2006/main">
+            <a:r>
+              <a:t>최신 원문·판정: https://github.com/SonJH0/aisupport/blob/main/docs/verification/latest-text-revalidation.md</a:t>
+            </a:r>
+          </a:p>
+          <a:p xmlns:a="http://schemas.openxmlformats.org/drawingml/2006/main">
+            <a:r>
+              <a:t>수집 스크립트는 실행 중 배포 SHA를 독립 관찰하지 않았다. 최신 비교 3/3, 상담 1건·검색 2건의 선택 시험. 전체 기능 새 3회 시험으로 합산하지 않는다.</a:t>
             </a:r>
           </a:p>
         </p:txBody>
@@ -3802,12 +3842,12 @@
   </p:cSld>
   <p:clrMap bg1="lt1" tx1="dk1" bg2="lt2" tx2="dk2" accent1="accent1" accent2="accent2" accent3="accent3" accent4="accent4" accent5="accent5" accent6="accent6" hlink="hlink" folHlink="folHlink"/>
   <p:sldLayoutIdLst>
-    <p:sldLayoutId xmlns:r="http://schemas.openxmlformats.org/officeDocument/2006/relationships" id="2147483649" r:id="R7fa4d22e98ae44e3"/>
-    <p:sldLayoutId xmlns:r="http://schemas.openxmlformats.org/officeDocument/2006/relationships" id="2147483650" r:id="R83583782afa1416c"/>
-    <p:sldLayoutId xmlns:r="http://schemas.openxmlformats.org/officeDocument/2006/relationships" id="2147483651" r:id="Rd4f827288f254ccc"/>
-    <p:sldLayoutId xmlns:r="http://schemas.openxmlformats.org/officeDocument/2006/relationships" id="2147483652" r:id="R67832741aa1f4601"/>
-    <p:sldLayoutId xmlns:r="http://schemas.openxmlformats.org/officeDocument/2006/relationships" id="2147483653" r:id="R13b01eac85244474"/>
-    <p:sldLayoutId xmlns:r="http://schemas.openxmlformats.org/officeDocument/2006/relationships" id="2147483654" r:id="R6ec6d2315f394bcd"/>
+    <p:sldLayoutId xmlns:r="http://schemas.openxmlformats.org/officeDocument/2006/relationships" id="2147483649" r:id="R6affb155d87b4819"/>
+    <p:sldLayoutId xmlns:r="http://schemas.openxmlformats.org/officeDocument/2006/relationships" id="2147483650" r:id="R5fb6e2c6e91548a9"/>
+    <p:sldLayoutId xmlns:r="http://schemas.openxmlformats.org/officeDocument/2006/relationships" id="2147483651" r:id="Rd72d9e2c1a954df4"/>
+    <p:sldLayoutId xmlns:r="http://schemas.openxmlformats.org/officeDocument/2006/relationships" id="2147483652" r:id="Re8c6646021124c21"/>
+    <p:sldLayoutId xmlns:r="http://schemas.openxmlformats.org/officeDocument/2006/relationships" id="2147483653" r:id="R2546bd52a8444b8d"/>
+    <p:sldLayoutId xmlns:r="http://schemas.openxmlformats.org/officeDocument/2006/relationships" id="2147483654" r:id="R990ad2c2d6dd4b50"/>
   </p:sldLayoutIdLst>
   <p:txStyles>
     <p:titleStyle>
@@ -6396,7 +6436,7 @@
           <p:cNvPr id="5" name="">
             <a:extLst xmlns:a="http://schemas.openxmlformats.org/drawingml/2006/main">
               <a:ext uri="{FF2B5EF4-FFF2-40B4-BE49-F238E27FC236}">
-                <a16:creationId xmlns:a16="http://schemas.microsoft.com/office/drawing/2014/main" id="{186FF293-605B-403C-B109-04E7EE3EB342}"/>
+                <a16:creationId xmlns:a16="http://schemas.microsoft.com/office/drawing/2014/main" id="{80EED100-1172-46B6-8C84-F8A34270381F}"/>
               </a:ext>
             </a:extLst>
           </p:cNvPr>
@@ -8648,7 +8688,7 @@
                 <a:ea typeface="Noto Sans KR"/>
                 <a:cs typeface="Noto Sans KR"/>
               </a:rPr>
-              <a:t>후속 bb1885e 수정은 별도 기술 시험에서 발견한 상담·검색 오류에 따른 작업입니다.</a:t>
+              <a:t>후속 bb1885e·4d0295b 수정은 별도 기술 시험에서 발견한 오류에 따른 작업입니다.</a:t>
             </a:r>
           </a:p>
         </p:txBody>
@@ -9363,7 +9403,7 @@
           <p:cNvPr id="5" name="">
             <a:extLst xmlns:a="http://schemas.openxmlformats.org/drawingml/2006/main">
               <a:ext uri="{FF2B5EF4-FFF2-40B4-BE49-F238E27FC236}">
-                <a16:creationId xmlns:a16="http://schemas.microsoft.com/office/drawing/2014/main" id="{DFD45A0A-671D-443F-AA33-9A0C464D1BE8}"/>
+                <a16:creationId xmlns:a16="http://schemas.microsoft.com/office/drawing/2014/main" id="{85AC70AE-2789-4F19-AF2E-17B643471212}"/>
               </a:ext>
             </a:extLst>
           </p:cNvPr>
@@ -11232,7 +11272,7 @@
                 <a:ea typeface="Noto Sans KR"/>
                 <a:cs typeface="Noto Sans KR"/>
               </a:rPr>
-              <a:t>남은 텍스트 회귀 확인과 제출 링크·서비스 유지 상태를 최종 점검합니다.</a:t>
+              <a:t>버전별 검증 범위를 구분하고 제출 링크·서비스 유지 상태를 최종 점검합니다.</a:t>
             </a:r>
           </a:p>
         </p:txBody>
@@ -13762,7 +13802,7 @@
           <p:cNvPr id="5" name="">
             <a:extLst xmlns:a="http://schemas.openxmlformats.org/drawingml/2006/main">
               <a:ext uri="{FF2B5EF4-FFF2-40B4-BE49-F238E27FC236}">
-                <a16:creationId xmlns:a16="http://schemas.microsoft.com/office/drawing/2014/main" id="{24B1DC82-5330-4CD7-BAE5-DFC79BFE7303}"/>
+                <a16:creationId xmlns:a16="http://schemas.microsoft.com/office/drawing/2014/main" id="{16AD35BE-F467-4E53-B900-95142217EF41}"/>
               </a:ext>
             </a:extLst>
           </p:cNvPr>
@@ -15338,7 +15378,7 @@
           <p:cNvPr id="5" name="">
             <a:extLst xmlns:a="http://schemas.openxmlformats.org/drawingml/2006/main">
               <a:ext uri="{FF2B5EF4-FFF2-40B4-BE49-F238E27FC236}">
-                <a16:creationId xmlns:a16="http://schemas.microsoft.com/office/drawing/2014/main" id="{8228A59C-DBB8-4D60-81E8-C218C1408190}"/>
+                <a16:creationId xmlns:a16="http://schemas.microsoft.com/office/drawing/2014/main" id="{E3CA4CCD-E02C-42F3-8FB4-871BCA97A708}"/>
               </a:ext>
             </a:extLst>
           </p:cNvPr>
@@ -16914,7 +16954,7 @@
           <p:cNvPr id="5" name="">
             <a:extLst xmlns:a="http://schemas.openxmlformats.org/drawingml/2006/main">
               <a:ext uri="{FF2B5EF4-FFF2-40B4-BE49-F238E27FC236}">
-                <a16:creationId xmlns:a16="http://schemas.microsoft.com/office/drawing/2014/main" id="{0340CA27-F10B-4990-BB98-F9B28967A427}"/>
+                <a16:creationId xmlns:a16="http://schemas.microsoft.com/office/drawing/2014/main" id="{6E737F0D-C781-465D-AABA-CC8E399FAC3A}"/>
               </a:ext>
             </a:extLst>
           </p:cNvPr>
@@ -18630,7 +18670,7 @@
                 <a:ea typeface="Noto Sans KR"/>
                 <a:cs typeface="Noto Sans KR"/>
               </a:rPr>
-              <a:t>질문마다 TF-IDF·코사인 유사도로</a:t>
+              <a:t>학습 질문마다 TF-IDF·코사인 유사도로</a:t>
             </a:r>
           </a:p>
           <a:p xmlns:a="http://schemas.openxmlformats.org/drawingml/2006/main">
@@ -18712,7 +18752,7 @@
           <p:cNvPr id="7" name="">
             <a:extLst xmlns:a="http://schemas.openxmlformats.org/drawingml/2006/main">
               <a:ext uri="{FF2B5EF4-FFF2-40B4-BE49-F238E27FC236}">
-                <a16:creationId xmlns:a16="http://schemas.microsoft.com/office/drawing/2014/main" id="{4272FD53-C9E3-4825-A8A0-16E6C825C3A9}"/>
+                <a16:creationId xmlns:a16="http://schemas.microsoft.com/office/drawing/2014/main" id="{CA866131-FA99-4641-8FDA-6C191FD1D402}"/>
               </a:ext>
             </a:extLst>
           </p:cNvPr>
@@ -19638,7 +19678,7 @@
                 <a:ea typeface="Noto Sans KR"/>
                 <a:cs typeface="Noto Sans KR"/>
               </a:rPr>
-              <a:t>초기 검색 필터와 후속 상담 오류를 기술 검증으로 보완했습니다.</a:t>
+              <a:t>홈페이지 혼입과 경험 분류를 후속 기술 시험으로 보완했습니다.</a:t>
             </a:r>
           </a:p>
         </p:txBody>
@@ -19986,7 +20026,7 @@
           <p:cNvPr id="5" name="">
             <a:extLst xmlns:a="http://schemas.openxmlformats.org/drawingml/2006/main">
               <a:ext uri="{FF2B5EF4-FFF2-40B4-BE49-F238E27FC236}">
-                <a16:creationId xmlns:a16="http://schemas.microsoft.com/office/drawing/2014/main" id="{B0198857-54CE-4107-8787-125690D35F45}"/>
+                <a16:creationId xmlns:a16="http://schemas.microsoft.com/office/drawing/2014/main" id="{DA7A6B20-7B74-4758-8718-5C64E01163A5}"/>
               </a:ext>
             </a:extLst>
           </p:cNvPr>
@@ -20127,7 +20167,7 @@
                           <a:ea typeface="Noto Sans KR"/>
                           <a:cs typeface="Noto Sans KR"/>
                         </a:rPr>
-                        <a:t>강의·검색 목록이 공고에 혼입</a:t>
+                        <a:t>홈페이지·검색 목록이 공고에 혼입</a:t>
                       </a:r>
                     </a:p>
                   </a:txBody>
@@ -20174,7 +20214,7 @@
                           <a:ea typeface="Noto Sans KR"/>
                           <a:cs typeface="Noto Sans KR"/>
                         </a:rPr>
-                        <a:t>페이지 유형 필터와 개별 후보 표시</a:t>
+                        <a:t>루트 홈페이지 제외·개별 공고 유지</a:t>
                       </a:r>
                     </a:p>
                   </a:txBody>
@@ -20217,7 +20257,7 @@
                           <a:ea typeface="Noto Sans KR"/>
                           <a:cs typeface="Noto Sans KR"/>
                         </a:rPr>
-                        <a:t>신입 제목과 경력 하한의 충돌</a:t>
+                        <a:t>경험 유무와 숙련도 혼합</a:t>
                       </a:r>
                     </a:p>
                   </a:txBody>
@@ -20264,7 +20304,7 @@
                           <a:ea typeface="Noto Sans KR"/>
                           <a:cs typeface="Noto Sans KR"/>
                         </a:rPr>
-                        <a:t>경력 하한을 확인해 충돌 결과 제외</a:t>
+                        <a:t>경험 상태와 숙련도 확인 분리</a:t>
                       </a:r>
                     </a:p>
                   </a:txBody>
@@ -20397,7 +20437,7 @@
                           <a:ea typeface="Noto Sans KR"/>
                           <a:cs typeface="Noto Sans KR"/>
                         </a:rPr>
-                        <a:t>목록 누락·일반 상담 계획 오류</a:t>
+                        <a:t>원치 않는 검색·비교 출처 혼입</a:t>
                       </a:r>
                     </a:p>
                   </a:txBody>
@@ -20444,7 +20484,7 @@
                           <a:ea typeface="Noto Sans KR"/>
                           <a:cs typeface="Noto Sans KR"/>
                         </a:rPr>
-                        <a:t>목록 필터·도구 없는 상담·검색 거부 처리</a:t>
+                        <a:t>검색 의도 확인·비교 초기 검색 생략</a:t>
                       </a:r>
                     </a:p>
                   </a:txBody>
@@ -20635,7 +20675,7 @@
                 <a:ea typeface="Noto Sans KR"/>
                 <a:cs typeface="Noto Sans KR"/>
               </a:rPr>
-              <a:t>초기 필터 보완 후 bb1885e에서 상담·검색 의도 처리를 보완했습니다. 모든 사이트를 보장하지는 않습니다.</a:t>
+              <a:t>bb1885e 상담 보완 후 4d0295b에서 홈페이지·경험 분류를 보완했습니다. 이전 실패도 보존합니다.</a:t>
             </a:r>
           </a:p>
         </p:txBody>
@@ -21002,7 +21042,7 @@
                 <a:ea typeface="Noto Sans KR"/>
                 <a:cs typeface="Noto Sans KR"/>
               </a:rPr>
-              <a:t>수정 전 시험과 bb1885e의 선택 회귀 시험을 구분했습니다.</a:t>
+              <a:t>최신 선택 API 6건과 기존 이미지 시험을 구분해 기록했습니다.</a:t>
             </a:r>
           </a:p>
         </p:txBody>
@@ -21350,7 +21390,7 @@
           <p:cNvPr id="5" name="">
             <a:extLst xmlns:a="http://schemas.openxmlformats.org/drawingml/2006/main">
               <a:ext uri="{FF2B5EF4-FFF2-40B4-BE49-F238E27FC236}">
-                <a16:creationId xmlns:a16="http://schemas.microsoft.com/office/drawing/2014/main" id="{F8F87CDB-BFA0-4631-AA14-D5CDD3D98D50}"/>
+                <a16:creationId xmlns:a16="http://schemas.microsoft.com/office/drawing/2014/main" id="{9F265B96-1A4D-429A-AB3D-FD5F13A6E9E4}"/>
               </a:ext>
             </a:extLst>
           </p:cNvPr>
@@ -21586,7 +21626,7 @@
                           <a:ea typeface="Noto Sans KR"/>
                           <a:cs typeface="Noto Sans KR"/>
                         </a:rPr>
-                        <a:t>수정 전 백엔드·프론트·pandas 3회</a:t>
+                        <a:t>이전 MDN·pandas / 최신 FastAPI 1건</a:t>
                       </a:r>
                     </a:p>
                   </a:txBody>
@@ -21627,7 +21667,7 @@
                           <a:ea typeface="Noto Sans KR"/>
                           <a:cs typeface="Noto Sans KR"/>
                         </a:rPr>
-                        <a:t>3/3 문단·출처·조언 확인</a:t>
+                        <a:t>관련 문단·출처·학습 조언 확인</a:t>
                       </a:r>
                     </a:p>
                   </a:txBody>
@@ -21717,7 +21757,7 @@
                           <a:ea typeface="Noto Sans KR"/>
                           <a:cs typeface="Noto Sans KR"/>
                         </a:rPr>
-                        <a:t>수정 전 3종 / 수정 후 Python 1회</a:t>
+                        <a:t>최신 Java·React 검색 2건</a:t>
                       </a:r>
                     </a:p>
                   </a:txBody>
@@ -21758,7 +21798,7 @@
                           <a:ea typeface="Noto Sans KR"/>
                           <a:cs typeface="Noto Sans KR"/>
                         </a:rPr>
-                        <a:t>후보·링크 확인 / 모집 상태 미확인</a:t>
+                        <a:t>개별 후보·링크·홈페이지 미노출</a:t>
                       </a:r>
                     </a:p>
                   </a:txBody>
@@ -21848,7 +21888,7 @@
                           <a:ea typeface="Noto Sans KR"/>
                           <a:cs typeface="Noto Sans KR"/>
                         </a:rPr>
-                        <a:t>수정 전 3개 입력 사례</a:t>
+                        <a:t>최신 비교 입력 3건</a:t>
                       </a:r>
                     </a:p>
                   </a:txBody>
@@ -21889,7 +21929,7 @@
                           <a:ea typeface="Noto Sans KR"/>
                           <a:cs typeface="Noto Sans KR"/>
                         </a:rPr>
-                        <a:t>2/3 충족·1회 부분 충족</a:t>
+                        <a:t>3/3 핵심 기대 결과 충족</a:t>
                       </a:r>
                     </a:p>
                   </a:txBody>
@@ -21979,7 +22019,7 @@
                           <a:ea typeface="Noto Sans KR"/>
                           <a:cs typeface="Noto Sans KR"/>
                         </a:rPr>
-                        <a:t>API 3회 / 사용자 화면 3회</a:t>
+                        <a:t>기존 API 3회 / 사용자 화면 3회</a:t>
                       </a:r>
                     </a:p>
                   </a:txBody>
@@ -22211,7 +22251,7 @@
                 <a:ea typeface="Noto Sans KR"/>
                 <a:cs typeface="Noto Sans KR"/>
               </a:rPr>
-              <a:t>기존 74개·보완 97개 자동 검사 기록. 수정 전 시험과 최신 회귀 결과는 합산하지 않습니다.</a:t>
+              <a:t>자동 검사 113개. 최신 API 6건의 핵심 기대 결과 확인. 502는 이번에 미재현, 원인은 미확정입니다.</a:t>
             </a:r>
           </a:p>
         </p:txBody>
@@ -22926,7 +22966,7 @@
           <p:cNvPr id="5" name="">
             <a:extLst xmlns:a="http://schemas.openxmlformats.org/drawingml/2006/main">
               <a:ext uri="{FF2B5EF4-FFF2-40B4-BE49-F238E27FC236}">
-                <a16:creationId xmlns:a16="http://schemas.microsoft.com/office/drawing/2014/main" id="{B81951E7-1FB8-4E64-8E57-1ACDDFED0514}"/>
+                <a16:creationId xmlns:a16="http://schemas.microsoft.com/office/drawing/2014/main" id="{717162B8-8DF8-4949-8039-1ACDD96B78A7}"/>
               </a:ext>
             </a:extLst>
           </p:cNvPr>
@@ -22936,7 +22976,7 @@
           <p:nvPr/>
         </p:nvPicPr>
         <p:blipFill>
-          <a:blip xmlns:r="http://schemas.openxmlformats.org/officeDocument/2006/relationships" xmlns:a="http://schemas.openxmlformats.org/drawingml/2006/main" r:embed="R6056c86905764d42"/>
+          <a:blip xmlns:r="http://schemas.openxmlformats.org/officeDocument/2006/relationships" xmlns:a="http://schemas.openxmlformats.org/drawingml/2006/main" r:embed="Rd92ba9575d014b2c"/>
           <a:stretch xmlns:a="http://schemas.openxmlformats.org/drawingml/2006/main"/>
         </p:blipFill>
         <p:spPr>

</xml_diff>

<commit_message>
docs: record successful postdeploy learning and consent checks
</commit_message>
<xml_diff>
--- a/docs/presentation/presentation.pptx
+++ b/docs/presentation/presentation.pptx
@@ -2,25 +2,25 @@
 <file path=ppt/presentation.xml><?xml version="1.0" encoding="utf-8"?>
 <p:presentation xmlns:p="http://schemas.openxmlformats.org/presentationml/2006/main">
   <p:sldMasterIdLst>
-    <p:sldMasterId xmlns:r="http://schemas.openxmlformats.org/officeDocument/2006/relationships" id="2147483648" r:id="R9045f5373f184d15"/>
+    <p:sldMasterId xmlns:r="http://schemas.openxmlformats.org/officeDocument/2006/relationships" id="2147483648" r:id="R4c5f2552b5fe471d"/>
   </p:sldMasterIdLst>
   <p:notesMasterIdLst>
-    <p:notesMasterId xmlns:r="http://schemas.openxmlformats.org/officeDocument/2006/relationships" r:id="Ra58a87526853478a"/>
+    <p:notesMasterId xmlns:r="http://schemas.openxmlformats.org/officeDocument/2006/relationships" r:id="Rb606214eb9d84d5a"/>
   </p:notesMasterIdLst>
   <p:sldIdLst>
-    <p:sldId xmlns:r="http://schemas.openxmlformats.org/officeDocument/2006/relationships" id="256" r:id="Re89b53c03b664748"/>
-    <p:sldId xmlns:r="http://schemas.openxmlformats.org/officeDocument/2006/relationships" id="257" r:id="Re2136ef7367b47ad"/>
-    <p:sldId xmlns:r="http://schemas.openxmlformats.org/officeDocument/2006/relationships" id="258" r:id="Rad409e6d288443e3"/>
-    <p:sldId xmlns:r="http://schemas.openxmlformats.org/officeDocument/2006/relationships" id="259" r:id="R9e21099f526d4c2e"/>
-    <p:sldId xmlns:r="http://schemas.openxmlformats.org/officeDocument/2006/relationships" id="260" r:id="R4101a32b0c28406d"/>
-    <p:sldId xmlns:r="http://schemas.openxmlformats.org/officeDocument/2006/relationships" id="261" r:id="Rb5a8b14635484f61"/>
-    <p:sldId xmlns:r="http://schemas.openxmlformats.org/officeDocument/2006/relationships" id="262" r:id="Rff0daa595e9145b7"/>
-    <p:sldId xmlns:r="http://schemas.openxmlformats.org/officeDocument/2006/relationships" id="263" r:id="R543570dc08074003"/>
-    <p:sldId xmlns:r="http://schemas.openxmlformats.org/officeDocument/2006/relationships" id="264" r:id="Reae3fd6ee0f74285"/>
-    <p:sldId xmlns:r="http://schemas.openxmlformats.org/officeDocument/2006/relationships" id="265" r:id="Rdb61409a960545b6"/>
-    <p:sldId xmlns:r="http://schemas.openxmlformats.org/officeDocument/2006/relationships" id="266" r:id="R1a70af13fae3484b"/>
-    <p:sldId xmlns:r="http://schemas.openxmlformats.org/officeDocument/2006/relationships" id="267" r:id="Rc1fe51597feb4584"/>
-    <p:sldId xmlns:r="http://schemas.openxmlformats.org/officeDocument/2006/relationships" id="268" r:id="R0fe67e8af96c481a"/>
+    <p:sldId xmlns:r="http://schemas.openxmlformats.org/officeDocument/2006/relationships" id="256" r:id="Rb44e79c88acb4d1c"/>
+    <p:sldId xmlns:r="http://schemas.openxmlformats.org/officeDocument/2006/relationships" id="257" r:id="R8249e785210f4a51"/>
+    <p:sldId xmlns:r="http://schemas.openxmlformats.org/officeDocument/2006/relationships" id="258" r:id="Re401e1d80266475c"/>
+    <p:sldId xmlns:r="http://schemas.openxmlformats.org/officeDocument/2006/relationships" id="259" r:id="R37414435c01c4533"/>
+    <p:sldId xmlns:r="http://schemas.openxmlformats.org/officeDocument/2006/relationships" id="260" r:id="Rf7ff9a97f1d24dfd"/>
+    <p:sldId xmlns:r="http://schemas.openxmlformats.org/officeDocument/2006/relationships" id="261" r:id="R5233978b1fa241e3"/>
+    <p:sldId xmlns:r="http://schemas.openxmlformats.org/officeDocument/2006/relationships" id="262" r:id="Re207cf53e93c41cc"/>
+    <p:sldId xmlns:r="http://schemas.openxmlformats.org/officeDocument/2006/relationships" id="263" r:id="R971793d235724488"/>
+    <p:sldId xmlns:r="http://schemas.openxmlformats.org/officeDocument/2006/relationships" id="264" r:id="R37c0dd1173744259"/>
+    <p:sldId xmlns:r="http://schemas.openxmlformats.org/officeDocument/2006/relationships" id="265" r:id="R7d52039b75414a09"/>
+    <p:sldId xmlns:r="http://schemas.openxmlformats.org/officeDocument/2006/relationships" id="266" r:id="R3bc1d6c1110e4ae4"/>
+    <p:sldId xmlns:r="http://schemas.openxmlformats.org/officeDocument/2006/relationships" id="267" r:id="R53a15d4bc4714216"/>
+    <p:sldId xmlns:r="http://schemas.openxmlformats.org/officeDocument/2006/relationships" id="268" r:id="R88aa007ac916417d"/>
   </p:sldIdLst>
   <p:sldSz cx="12192000" cy="6858000"/>
   <p:notesSz cx="6858000" cy="9144000"/>
@@ -617,6 +617,16 @@
               <a:t>수집 스크립트는 실행 중 배포 SHA를 독립 관찰하지 않았다. 최신 비교 3/3, 상담 1건·검색 2건의 선택 시험. 전체 기능 새 3회 시험으로 합산하지 않는다.</a:t>
             </a:r>
           </a:p>
+          <a:p xmlns:a="http://schemas.openxmlformats.org/drawingml/2006/main">
+            <a:r>
+              <a:t>최신 원문·판정: https://github.com/SonJH0/aisupport/blob/main/docs/verification/postdeploy-3719c28.md</a:t>
+            </a:r>
+          </a:p>
+          <a:p xmlns:a="http://schemas.openxmlformats.org/drawingml/2006/main">
+            <a:r>
+              <a:t>사용자 제공 Render 화면에서 source 3719c28·Live 확인. 배포 후 학습 상담 UI 3회·동의 절차 3회, 기존 검색·비교·이미지는 별도 시점의 기록으로 구분한다.</a:t>
+            </a:r>
+          </a:p>
         </p:txBody>
       </p:sp>
       <p:sp>
@@ -780,6 +790,16 @@
           <a:p xmlns:a="http://schemas.openxmlformats.org/drawingml/2006/main">
             <a:r>
               <a:t>수집 스크립트는 실행 중 배포 SHA를 독립 관찰하지 않았다. 최신 비교 3/3, 상담 1건·검색 2건의 선택 시험. 전체 기능 새 3회 시험으로 합산하지 않는다.</a:t>
+            </a:r>
+          </a:p>
+          <a:p xmlns:a="http://schemas.openxmlformats.org/drawingml/2006/main">
+            <a:r>
+              <a:t>최신 원문·판정: https://github.com/SonJH0/aisupport/blob/main/docs/verification/postdeploy-3719c28.md</a:t>
+            </a:r>
+          </a:p>
+          <a:p xmlns:a="http://schemas.openxmlformats.org/drawingml/2006/main">
+            <a:r>
+              <a:t>사용자 제공 Render 화면에서 source 3719c28·Live 확인. 배포 후 학습 상담 UI 3회·동의 절차 3회, 기존 검색·비교·이미지는 별도 시점의 기록으로 구분한다.</a:t>
             </a:r>
           </a:p>
         </p:txBody>
@@ -1237,6 +1257,16 @@
               <a:t>수집 스크립트는 실행 중 배포 SHA를 독립 관찰하지 않았다. 최신 비교 3/3, 상담 1건·검색 2건의 선택 시험. 전체 기능 새 3회 시험으로 합산하지 않는다.</a:t>
             </a:r>
           </a:p>
+          <a:p xmlns:a="http://schemas.openxmlformats.org/drawingml/2006/main">
+            <a:r>
+              <a:t>최신 원문·판정: https://github.com/SonJH0/aisupport/blob/main/docs/verification/postdeploy-3719c28.md</a:t>
+            </a:r>
+          </a:p>
+          <a:p xmlns:a="http://schemas.openxmlformats.org/drawingml/2006/main">
+            <a:r>
+              <a:t>사용자 제공 Render 화면에서 source 3719c28·Live 확인. 배포 후 학습 상담 UI 3회·동의 절차 3회, 기존 검색·비교·이미지는 별도 시점의 기록으로 구분한다.</a:t>
+            </a:r>
+          </a:p>
         </p:txBody>
       </p:sp>
       <p:sp>
@@ -1325,6 +1355,16 @@
           <a:p xmlns:a="http://schemas.openxmlformats.org/drawingml/2006/main">
             <a:r>
               <a:t>수집 스크립트는 실행 중 배포 SHA를 독립 관찰하지 않았다. 최신 비교 3/3, 상담 1건·검색 2건의 선택 시험. 전체 기능 새 3회 시험으로 합산하지 않는다.</a:t>
+            </a:r>
+          </a:p>
+          <a:p xmlns:a="http://schemas.openxmlformats.org/drawingml/2006/main">
+            <a:r>
+              <a:t>최신 원문·판정: https://github.com/SonJH0/aisupport/blob/main/docs/verification/postdeploy-3719c28.md</a:t>
+            </a:r>
+          </a:p>
+          <a:p xmlns:a="http://schemas.openxmlformats.org/drawingml/2006/main">
+            <a:r>
+              <a:t>사용자 제공 Render 화면에서 source 3719c28·Live 확인. 배포 후 학습 상담 UI 3회·동의 절차 3회, 기존 검색·비교·이미지는 별도 시점의 기록으로 구분한다.</a:t>
             </a:r>
           </a:p>
         </p:txBody>
@@ -3842,12 +3882,12 @@
   </p:cSld>
   <p:clrMap bg1="lt1" tx1="dk1" bg2="lt2" tx2="dk2" accent1="accent1" accent2="accent2" accent3="accent3" accent4="accent4" accent5="accent5" accent6="accent6" hlink="hlink" folHlink="folHlink"/>
   <p:sldLayoutIdLst>
-    <p:sldLayoutId xmlns:r="http://schemas.openxmlformats.org/officeDocument/2006/relationships" id="2147483649" r:id="R6affb155d87b4819"/>
-    <p:sldLayoutId xmlns:r="http://schemas.openxmlformats.org/officeDocument/2006/relationships" id="2147483650" r:id="R5fb6e2c6e91548a9"/>
-    <p:sldLayoutId xmlns:r="http://schemas.openxmlformats.org/officeDocument/2006/relationships" id="2147483651" r:id="Rd72d9e2c1a954df4"/>
-    <p:sldLayoutId xmlns:r="http://schemas.openxmlformats.org/officeDocument/2006/relationships" id="2147483652" r:id="Re8c6646021124c21"/>
-    <p:sldLayoutId xmlns:r="http://schemas.openxmlformats.org/officeDocument/2006/relationships" id="2147483653" r:id="R2546bd52a8444b8d"/>
-    <p:sldLayoutId xmlns:r="http://schemas.openxmlformats.org/officeDocument/2006/relationships" id="2147483654" r:id="R990ad2c2d6dd4b50"/>
+    <p:sldLayoutId xmlns:r="http://schemas.openxmlformats.org/officeDocument/2006/relationships" id="2147483649" r:id="R398ee19d82784925"/>
+    <p:sldLayoutId xmlns:r="http://schemas.openxmlformats.org/officeDocument/2006/relationships" id="2147483650" r:id="R31c7e5e8ecd94dc4"/>
+    <p:sldLayoutId xmlns:r="http://schemas.openxmlformats.org/officeDocument/2006/relationships" id="2147483651" r:id="R423277639b50412c"/>
+    <p:sldLayoutId xmlns:r="http://schemas.openxmlformats.org/officeDocument/2006/relationships" id="2147483652" r:id="R7d8917daffa74e1f"/>
+    <p:sldLayoutId xmlns:r="http://schemas.openxmlformats.org/officeDocument/2006/relationships" id="2147483653" r:id="Red5fd12f668d4906"/>
+    <p:sldLayoutId xmlns:r="http://schemas.openxmlformats.org/officeDocument/2006/relationships" id="2147483654" r:id="Rb9e6211a77f2428d"/>
   </p:sldLayoutIdLst>
   <p:txStyles>
     <p:titleStyle>
@@ -6436,7 +6476,7 @@
           <p:cNvPr id="5" name="">
             <a:extLst xmlns:a="http://schemas.openxmlformats.org/drawingml/2006/main">
               <a:ext uri="{FF2B5EF4-FFF2-40B4-BE49-F238E27FC236}">
-                <a16:creationId xmlns:a16="http://schemas.microsoft.com/office/drawing/2014/main" id="{80EED100-1172-46B6-8C84-F8A34270381F}"/>
+                <a16:creationId xmlns:a16="http://schemas.microsoft.com/office/drawing/2014/main" id="{AA929DDF-4FC5-4886-984C-2605403E98DF}"/>
               </a:ext>
             </a:extLst>
           </p:cNvPr>
@@ -9403,7 +9443,7 @@
           <p:cNvPr id="5" name="">
             <a:extLst xmlns:a="http://schemas.openxmlformats.org/drawingml/2006/main">
               <a:ext uri="{FF2B5EF4-FFF2-40B4-BE49-F238E27FC236}">
-                <a16:creationId xmlns:a16="http://schemas.microsoft.com/office/drawing/2014/main" id="{85AC70AE-2789-4F19-AF2E-17B643471212}"/>
+                <a16:creationId xmlns:a16="http://schemas.microsoft.com/office/drawing/2014/main" id="{9F98D037-4A83-4F3B-A039-BCC921E9D9FB}"/>
               </a:ext>
             </a:extLst>
           </p:cNvPr>
@@ -10133,7 +10173,7 @@
                 <a:ea typeface="Noto Sans KR"/>
                 <a:cs typeface="Noto Sans KR"/>
               </a:rPr>
-              <a:t>AI 고지·화면 동의 차단·서버 미동의 403 응답 3회를 확인했습니다.</a:t>
+              <a:t>AI 고지·미동의 화면 차단·동의 후 상담 3회, 서버 403·안내 본문 3회를 확인했습니다.</a:t>
             </a:r>
           </a:p>
           <a:p xmlns:a="http://schemas.openxmlformats.org/drawingml/2006/main">
@@ -13802,7 +13842,7 @@
           <p:cNvPr id="5" name="">
             <a:extLst xmlns:a="http://schemas.openxmlformats.org/drawingml/2006/main">
               <a:ext uri="{FF2B5EF4-FFF2-40B4-BE49-F238E27FC236}">
-                <a16:creationId xmlns:a16="http://schemas.microsoft.com/office/drawing/2014/main" id="{16AD35BE-F467-4E53-B900-95142217EF41}"/>
+                <a16:creationId xmlns:a16="http://schemas.microsoft.com/office/drawing/2014/main" id="{811C3681-94A2-45A8-8A1E-93DF8DB6556C}"/>
               </a:ext>
             </a:extLst>
           </p:cNvPr>
@@ -15378,7 +15418,7 @@
           <p:cNvPr id="5" name="">
             <a:extLst xmlns:a="http://schemas.openxmlformats.org/drawingml/2006/main">
               <a:ext uri="{FF2B5EF4-FFF2-40B4-BE49-F238E27FC236}">
-                <a16:creationId xmlns:a16="http://schemas.microsoft.com/office/drawing/2014/main" id="{E3CA4CCD-E02C-42F3-8FB4-871BCA97A708}"/>
+                <a16:creationId xmlns:a16="http://schemas.microsoft.com/office/drawing/2014/main" id="{0BEB5DFA-50AC-4D9E-B72C-BE6377868319}"/>
               </a:ext>
             </a:extLst>
           </p:cNvPr>
@@ -16954,7 +16994,7 @@
           <p:cNvPr id="5" name="">
             <a:extLst xmlns:a="http://schemas.openxmlformats.org/drawingml/2006/main">
               <a:ext uri="{FF2B5EF4-FFF2-40B4-BE49-F238E27FC236}">
-                <a16:creationId xmlns:a16="http://schemas.microsoft.com/office/drawing/2014/main" id="{6E737F0D-C781-465D-AABA-CC8E399FAC3A}"/>
+                <a16:creationId xmlns:a16="http://schemas.microsoft.com/office/drawing/2014/main" id="{D8489A91-5C4E-4F37-8E2F-F7B96B167F83}"/>
               </a:ext>
             </a:extLst>
           </p:cNvPr>
@@ -18752,7 +18792,7 @@
           <p:cNvPr id="7" name="">
             <a:extLst xmlns:a="http://schemas.openxmlformats.org/drawingml/2006/main">
               <a:ext uri="{FF2B5EF4-FFF2-40B4-BE49-F238E27FC236}">
-                <a16:creationId xmlns:a16="http://schemas.microsoft.com/office/drawing/2014/main" id="{CA866131-FA99-4641-8FDA-6C191FD1D402}"/>
+                <a16:creationId xmlns:a16="http://schemas.microsoft.com/office/drawing/2014/main" id="{4C96083D-072C-4E12-B3FC-E32E1048BFED}"/>
               </a:ext>
             </a:extLst>
           </p:cNvPr>
@@ -20026,7 +20066,7 @@
           <p:cNvPr id="5" name="">
             <a:extLst xmlns:a="http://schemas.openxmlformats.org/drawingml/2006/main">
               <a:ext uri="{FF2B5EF4-FFF2-40B4-BE49-F238E27FC236}">
-                <a16:creationId xmlns:a16="http://schemas.microsoft.com/office/drawing/2014/main" id="{DA7A6B20-7B74-4758-8718-5C64E01163A5}"/>
+                <a16:creationId xmlns:a16="http://schemas.microsoft.com/office/drawing/2014/main" id="{3399F7C6-BED0-4A08-80E8-B9B19F6BAAA3}"/>
               </a:ext>
             </a:extLst>
           </p:cNvPr>
@@ -20675,7 +20715,7 @@
                 <a:ea typeface="Noto Sans KR"/>
                 <a:cs typeface="Noto Sans KR"/>
               </a:rPr>
-              <a:t>bb1885e 상담 보완 후 4d0295b에서 홈페이지·경험 분류를 보완했습니다. 이전 실패도 보존합니다.</a:t>
+              <a:t>홈페이지·경험 분류 보완 후 3719c28에서 학습 계획 복구를 추가했습니다. 이전 실패도 보존합니다.</a:t>
             </a:r>
           </a:p>
         </p:txBody>
@@ -21042,7 +21082,7 @@
                 <a:ea typeface="Noto Sans KR"/>
                 <a:cs typeface="Noto Sans KR"/>
               </a:rPr>
-              <a:t>최신 선택 API 6건과 기존 이미지 시험을 구분해 기록했습니다.</a:t>
+              <a:t>3719c28 배포 후 상담 화면 3회와 기존 기능 검증을 구분했습니다.</a:t>
             </a:r>
           </a:p>
         </p:txBody>
@@ -21390,7 +21430,7 @@
           <p:cNvPr id="5" name="">
             <a:extLst xmlns:a="http://schemas.openxmlformats.org/drawingml/2006/main">
               <a:ext uri="{FF2B5EF4-FFF2-40B4-BE49-F238E27FC236}">
-                <a16:creationId xmlns:a16="http://schemas.microsoft.com/office/drawing/2014/main" id="{9F265B96-1A4D-429A-AB3D-FD5F13A6E9E4}"/>
+                <a16:creationId xmlns:a16="http://schemas.microsoft.com/office/drawing/2014/main" id="{7988813D-76C4-400A-82D2-5B40AF2A7D17}"/>
               </a:ext>
             </a:extLst>
           </p:cNvPr>
@@ -21626,7 +21666,7 @@
                           <a:ea typeface="Noto Sans KR"/>
                           <a:cs typeface="Noto Sans KR"/>
                         </a:rPr>
-                        <a:t>이전 MDN·pandas / 최신 FastAPI 1건</a:t>
+                        <a:t>배포 후 FastAPI·MDN·pandas 3회</a:t>
                       </a:r>
                     </a:p>
                   </a:txBody>
@@ -21667,7 +21707,7 @@
                           <a:ea typeface="Noto Sans KR"/>
                           <a:cs typeface="Noto Sans KR"/>
                         </a:rPr>
-                        <a:t>관련 문단·출처·학습 조언 확인</a:t>
+                        <a:t>3/3 관련 자료·출처·조언 확인</a:t>
                       </a:r>
                     </a:p>
                   </a:txBody>
@@ -21757,7 +21797,7 @@
                           <a:ea typeface="Noto Sans KR"/>
                           <a:cs typeface="Noto Sans KR"/>
                         </a:rPr>
-                        <a:t>최신 Java·React 검색 2건</a:t>
+                        <a:t>Java·React API / 후속 Python 화면</a:t>
                       </a:r>
                     </a:p>
                   </a:txBody>
@@ -22251,7 +22291,7 @@
                 <a:ea typeface="Noto Sans KR"/>
                 <a:cs typeface="Noto Sans KR"/>
               </a:rPr>
-              <a:t>자동 검사 113개. 최신 API 6건의 핵심 기대 결과 확인. 502는 이번에 미재현, 원인은 미확정입니다.</a:t>
+              <a:t>자동 검사 120개. 배포 후 학습 상담·동의 절차 3/3 확인. 과거 계획 오류·502 기록은 보존합니다.</a:t>
             </a:r>
           </a:p>
         </p:txBody>
@@ -22966,7 +23006,7 @@
           <p:cNvPr id="5" name="">
             <a:extLst xmlns:a="http://schemas.openxmlformats.org/drawingml/2006/main">
               <a:ext uri="{FF2B5EF4-FFF2-40B4-BE49-F238E27FC236}">
-                <a16:creationId xmlns:a16="http://schemas.microsoft.com/office/drawing/2014/main" id="{717162B8-8DF8-4949-8039-1ACDD96B78A7}"/>
+                <a16:creationId xmlns:a16="http://schemas.microsoft.com/office/drawing/2014/main" id="{8376254C-1424-44D7-A890-A9B1C2603958}"/>
               </a:ext>
             </a:extLst>
           </p:cNvPr>
@@ -22976,7 +23016,7 @@
           <p:nvPr/>
         </p:nvPicPr>
         <p:blipFill>
-          <a:blip xmlns:r="http://schemas.openxmlformats.org/officeDocument/2006/relationships" xmlns:a="http://schemas.openxmlformats.org/drawingml/2006/main" r:embed="Rd92ba9575d014b2c"/>
+          <a:blip xmlns:r="http://schemas.openxmlformats.org/officeDocument/2006/relationships" xmlns:a="http://schemas.openxmlformats.org/drawingml/2006/main" r:embed="Rba30aee1e2194648"/>
           <a:stretch xmlns:a="http://schemas.openxmlformats.org/drawingml/2006/main"/>
         </p:blipFill>
         <p:spPr>

</xml_diff>